<commit_message>
Add point on nonce issuance preventing double spending prob.
</commit_message>
<xml_diff>
--- a/my_resume_v2.pptx
+++ b/my_resume_v2.pptx
@@ -198,7 +198,7 @@
           <a:p>
             <a:fld id="{060BEAD1-672E-E841-95FA-08B9B35A46D7}" type="datetimeFigureOut">
               <a:rPr lang="en-US" smtClean="0"/>
-              <a:t>12/24/25</a:t>
+              <a:t>1/11/26</a:t>
             </a:fld>
             <a:endParaRPr lang="en-US"/>
           </a:p>
@@ -765,7 +765,7 @@
           <a:p>
             <a:fld id="{A417C049-F611-094D-8104-5764D8D04213}" type="datetimeFigureOut">
               <a:rPr lang="en-US" smtClean="0"/>
-              <a:t>12/24/25</a:t>
+              <a:t>1/11/26</a:t>
             </a:fld>
             <a:endParaRPr lang="en-US"/>
           </a:p>
@@ -935,7 +935,7 @@
           <a:p>
             <a:fld id="{A417C049-F611-094D-8104-5764D8D04213}" type="datetimeFigureOut">
               <a:rPr lang="en-US" smtClean="0"/>
-              <a:t>12/24/25</a:t>
+              <a:t>1/11/26</a:t>
             </a:fld>
             <a:endParaRPr lang="en-US"/>
           </a:p>
@@ -1115,7 +1115,7 @@
           <a:p>
             <a:fld id="{A417C049-F611-094D-8104-5764D8D04213}" type="datetimeFigureOut">
               <a:rPr lang="en-US" smtClean="0"/>
-              <a:t>12/24/25</a:t>
+              <a:t>1/11/26</a:t>
             </a:fld>
             <a:endParaRPr lang="en-US"/>
           </a:p>
@@ -1285,7 +1285,7 @@
           <a:p>
             <a:fld id="{A417C049-F611-094D-8104-5764D8D04213}" type="datetimeFigureOut">
               <a:rPr lang="en-US" smtClean="0"/>
-              <a:t>12/24/25</a:t>
+              <a:t>1/11/26</a:t>
             </a:fld>
             <a:endParaRPr lang="en-US"/>
           </a:p>
@@ -1529,7 +1529,7 @@
           <a:p>
             <a:fld id="{A417C049-F611-094D-8104-5764D8D04213}" type="datetimeFigureOut">
               <a:rPr lang="en-US" smtClean="0"/>
-              <a:t>12/24/25</a:t>
+              <a:t>1/11/26</a:t>
             </a:fld>
             <a:endParaRPr lang="en-US"/>
           </a:p>
@@ -1761,7 +1761,7 @@
           <a:p>
             <a:fld id="{A417C049-F611-094D-8104-5764D8D04213}" type="datetimeFigureOut">
               <a:rPr lang="en-US" smtClean="0"/>
-              <a:t>12/24/25</a:t>
+              <a:t>1/11/26</a:t>
             </a:fld>
             <a:endParaRPr lang="en-US"/>
           </a:p>
@@ -2128,7 +2128,7 @@
           <a:p>
             <a:fld id="{A417C049-F611-094D-8104-5764D8D04213}" type="datetimeFigureOut">
               <a:rPr lang="en-US" smtClean="0"/>
-              <a:t>12/24/25</a:t>
+              <a:t>1/11/26</a:t>
             </a:fld>
             <a:endParaRPr lang="en-US"/>
           </a:p>
@@ -2246,7 +2246,7 @@
           <a:p>
             <a:fld id="{A417C049-F611-094D-8104-5764D8D04213}" type="datetimeFigureOut">
               <a:rPr lang="en-US" smtClean="0"/>
-              <a:t>12/24/25</a:t>
+              <a:t>1/11/26</a:t>
             </a:fld>
             <a:endParaRPr lang="en-US"/>
           </a:p>
@@ -2341,7 +2341,7 @@
           <a:p>
             <a:fld id="{A417C049-F611-094D-8104-5764D8D04213}" type="datetimeFigureOut">
               <a:rPr lang="en-US" smtClean="0"/>
-              <a:t>12/24/25</a:t>
+              <a:t>1/11/26</a:t>
             </a:fld>
             <a:endParaRPr lang="en-US"/>
           </a:p>
@@ -2618,7 +2618,7 @@
           <a:p>
             <a:fld id="{A417C049-F611-094D-8104-5764D8D04213}" type="datetimeFigureOut">
               <a:rPr lang="en-US" smtClean="0"/>
-              <a:t>12/24/25</a:t>
+              <a:t>1/11/26</a:t>
             </a:fld>
             <a:endParaRPr lang="en-US"/>
           </a:p>
@@ -2875,7 +2875,7 @@
           <a:p>
             <a:fld id="{A417C049-F611-094D-8104-5764D8D04213}" type="datetimeFigureOut">
               <a:rPr lang="en-US" smtClean="0"/>
-              <a:t>12/24/25</a:t>
+              <a:t>1/11/26</a:t>
             </a:fld>
             <a:endParaRPr lang="en-US"/>
           </a:p>
@@ -3093,7 +3093,7 @@
           <a:p>
             <a:fld id="{A417C049-F611-094D-8104-5764D8D04213}" type="datetimeFigureOut">
               <a:rPr lang="en-US" smtClean="0"/>
-              <a:t>12/24/25</a:t>
+              <a:t>1/11/26</a:t>
             </a:fld>
             <a:endParaRPr lang="en-US"/>
           </a:p>
@@ -5840,7 +5840,7 @@
         </p:nvGrpSpPr>
         <p:grpSpPr>
           <a:xfrm>
-            <a:off x="126723" y="3627230"/>
+            <a:off x="126723" y="3612509"/>
             <a:ext cx="1502200" cy="292388"/>
             <a:chOff x="4141297" y="2671400"/>
             <a:chExt cx="1502200" cy="292388"/>
@@ -5936,7 +5936,7 @@
         </p:nvSpPr>
         <p:spPr>
           <a:xfrm>
-            <a:off x="88190" y="8313796"/>
+            <a:off x="88190" y="8332663"/>
             <a:ext cx="6657120" cy="1536639"/>
           </a:xfrm>
           <a:prstGeom prst="rect">
@@ -6481,7 +6481,7 @@
         </p:nvSpPr>
         <p:spPr>
           <a:xfrm>
-            <a:off x="88190" y="6034837"/>
+            <a:off x="88190" y="6035598"/>
             <a:ext cx="6657120" cy="1395575"/>
           </a:xfrm>
           <a:prstGeom prst="rect">
@@ -7159,7 +7159,7 @@
         </p:nvSpPr>
         <p:spPr>
           <a:xfrm>
-            <a:off x="88190" y="7455080"/>
+            <a:off x="88190" y="7464894"/>
             <a:ext cx="6657120" cy="831318"/>
           </a:xfrm>
           <a:prstGeom prst="rect">
@@ -7410,8 +7410,8 @@
         </p:nvSpPr>
         <p:spPr>
           <a:xfrm>
-            <a:off x="87378" y="3911213"/>
-            <a:ext cx="6657120" cy="2100896"/>
+            <a:off x="87378" y="3902513"/>
+            <a:ext cx="6657120" cy="2100190"/>
           </a:xfrm>
           <a:prstGeom prst="rect">
             <a:avLst/>
@@ -7457,7 +7457,7 @@
               <a:buChar char="•"/>
             </a:pPr>
             <a:r>
-              <a:rPr lang="en-US" sz="900" dirty="0">
+              <a:rPr lang="en-US" sz="890" dirty="0">
                 <a:solidFill>
                   <a:schemeClr val="tx1">
                     <a:lumMod val="75000"/>
@@ -7468,29 +7468,29 @@
               <a:t>Researched &amp; developed a novel highly scalable </a:t>
             </a:r>
             <a:r>
-              <a:rPr lang="en-US" sz="900" u="sng" dirty="0">
-                <a:solidFill>
-                  <a:schemeClr val="tx1">
-                    <a:lumMod val="75000"/>
-                    <a:lumOff val="25000"/>
-                  </a:schemeClr>
-                </a:solidFill>
-              </a:rPr>
-              <a:t>EVM Gasless Execution Engine </a:t>
-            </a:r>
-            <a:r>
-              <a:rPr lang="en-US" sz="900" dirty="0">
-                <a:solidFill>
-                  <a:schemeClr val="tx1">
-                    <a:lumMod val="75000"/>
-                    <a:lumOff val="25000"/>
-                  </a:schemeClr>
-                </a:solidFill>
-              </a:rPr>
-              <a:t>lowering on-chain fees by upto ↓</a:t>
-            </a:r>
-            <a:r>
-              <a:rPr lang="en-US" sz="900" u="sng" dirty="0">
+              <a:rPr lang="en-US" sz="890" u="sng" dirty="0">
+                <a:solidFill>
+                  <a:schemeClr val="tx1">
+                    <a:lumMod val="75000"/>
+                    <a:lumOff val="25000"/>
+                  </a:schemeClr>
+                </a:solidFill>
+              </a:rPr>
+              <a:t>EVM Gasless Execution Engine</a:t>
+            </a:r>
+            <a:r>
+              <a:rPr lang="en-US" sz="890" dirty="0">
+                <a:solidFill>
+                  <a:schemeClr val="tx1">
+                    <a:lumMod val="75000"/>
+                    <a:lumOff val="25000"/>
+                  </a:schemeClr>
+                </a:solidFill>
+              </a:rPr>
+              <a:t> lowering on-chain fees by upto ↓</a:t>
+            </a:r>
+            <a:r>
+              <a:rPr lang="en-US" sz="890" u="sng" dirty="0">
                 <a:solidFill>
                   <a:schemeClr val="tx1">
                     <a:lumMod val="75000"/>
@@ -7501,37 +7501,15 @@
               <a:t>84%</a:t>
             </a:r>
             <a:r>
-              <a:rPr lang="en-US" sz="900" dirty="0">
-                <a:solidFill>
-                  <a:schemeClr val="tx1">
-                    <a:lumMod val="75000"/>
-                    <a:lumOff val="25000"/>
-                  </a:schemeClr>
-                </a:solidFill>
-              </a:rPr>
-              <a:t> supporting both custodial/non-custodial wallets, keeping assets on L1 with no asset migration, instant finality. | Rust, Solidity, MongoDB, Redis, </a:t>
-            </a:r>
-            <a:r>
-              <a:rPr lang="en-US" sz="900" dirty="0" err="1">
-                <a:solidFill>
-                  <a:schemeClr val="tx1">
-                    <a:lumMod val="75000"/>
-                    <a:lumOff val="25000"/>
-                  </a:schemeClr>
-                </a:solidFill>
-              </a:rPr>
-              <a:t>PubSub</a:t>
-            </a:r>
-            <a:r>
-              <a:rPr lang="en-US" sz="900" dirty="0">
-                <a:solidFill>
-                  <a:schemeClr val="tx1">
-                    <a:lumMod val="75000"/>
-                    <a:lumOff val="25000"/>
-                  </a:schemeClr>
-                </a:solidFill>
-              </a:rPr>
-              <a:t>.</a:t>
+              <a:rPr lang="en-US" sz="890" dirty="0">
+                <a:solidFill>
+                  <a:schemeClr val="tx1">
+                    <a:lumMod val="75000"/>
+                    <a:lumOff val="25000"/>
+                  </a:schemeClr>
+                </a:solidFill>
+              </a:rPr>
+              <a:t> supporting both custodial/non-custodial wallets, keeping assets on L1 with no asset migration, instant finality. | Rust, Solidity, MongoDB, Redis, Pub-Sub.</a:t>
             </a:r>
           </a:p>
           <a:p>
@@ -7543,7 +7521,7 @@
               <a:buChar char="•"/>
             </a:pPr>
             <a:r>
-              <a:rPr lang="en-US" sz="900" dirty="0">
+              <a:rPr lang="en-US" sz="890" dirty="0">
                 <a:solidFill>
                   <a:schemeClr val="tx1">
                     <a:lumMod val="75000"/>
@@ -7554,7 +7532,7 @@
               <a:t>Building a permissionless gas </a:t>
             </a:r>
             <a:r>
-              <a:rPr lang="en-US" sz="900" dirty="0" err="1">
+              <a:rPr lang="en-US" sz="890" dirty="0" err="1">
                 <a:solidFill>
                   <a:schemeClr val="tx1">
                     <a:lumMod val="75000"/>
@@ -7565,7 +7543,7 @@
               <a:t>relayer</a:t>
             </a:r>
             <a:r>
-              <a:rPr lang="en-US" sz="900" dirty="0">
+              <a:rPr lang="en-US" sz="890" dirty="0">
                 <a:solidFill>
                   <a:schemeClr val="tx1">
                     <a:lumMod val="75000"/>
@@ -7576,7 +7554,7 @@
               <a:t> network — “Pulse” (on top of </a:t>
             </a:r>
             <a:r>
-              <a:rPr lang="en-US" sz="900" i="1" dirty="0">
+              <a:rPr lang="en-US" sz="890" i="1" dirty="0">
                 <a:solidFill>
                   <a:schemeClr val="tx1">
                     <a:lumMod val="75000"/>
@@ -7587,7 +7565,7 @@
               <a:t>Reth)</a:t>
             </a:r>
             <a:r>
-              <a:rPr lang="en-US" sz="900" dirty="0">
+              <a:rPr lang="en-US" sz="890" dirty="0">
                 <a:solidFill>
                   <a:schemeClr val="tx1">
                     <a:lumMod val="75000"/>
@@ -7607,18 +7585,18 @@
               <a:buChar char="•"/>
             </a:pPr>
             <a:r>
-              <a:rPr lang="en-US" sz="900" dirty="0">
-                <a:solidFill>
-                  <a:schemeClr val="tx1">
-                    <a:lumMod val="75000"/>
-                    <a:lumOff val="25000"/>
-                  </a:schemeClr>
-                </a:solidFill>
-              </a:rPr>
-              <a:t>Developed &amp; deployed a secure, gas-optimized </a:t>
-            </a:r>
-            <a:r>
-              <a:rPr lang="en-US" sz="900" dirty="0" err="1">
+              <a:rPr lang="en-US" sz="890" dirty="0">
+                <a:solidFill>
+                  <a:schemeClr val="tx1">
+                    <a:lumMod val="75000"/>
+                    <a:lumOff val="25000"/>
+                  </a:schemeClr>
+                </a:solidFill>
+              </a:rPr>
+              <a:t>Developed &amp; deployed a gas-optimized </a:t>
+            </a:r>
+            <a:r>
+              <a:rPr lang="en-US" sz="890" dirty="0" err="1">
                 <a:solidFill>
                   <a:schemeClr val="tx1">
                     <a:lumMod val="75000"/>
@@ -7629,15 +7607,15 @@
               <a:t>BundlePay</a:t>
             </a:r>
             <a:r>
-              <a:rPr lang="en-US" sz="900" dirty="0">
-                <a:solidFill>
-                  <a:schemeClr val="tx1">
-                    <a:lumMod val="75000"/>
-                    <a:lumOff val="25000"/>
-                  </a:schemeClr>
-                </a:solidFill>
-              </a:rPr>
-              <a:t> smart contract (with tests) for handling payments from custodial &amp; non-custodial wallets | Foundry, Solidity.</a:t>
+              <a:rPr lang="en-US" sz="890" dirty="0">
+                <a:solidFill>
+                  <a:schemeClr val="tx1">
+                    <a:lumMod val="75000"/>
+                    <a:lumOff val="25000"/>
+                  </a:schemeClr>
+                </a:solidFill>
+              </a:rPr>
+              <a:t> smart contract with Permit2 nonce management, combining on-chain bitmap analysis and off-chain issuance throttling to securely support concurrent, gasless custodial and non-custodial payments | Solidity, Foundry, Rust.</a:t>
             </a:r>
           </a:p>
           <a:p>
@@ -7649,7 +7627,7 @@
               <a:buChar char="•"/>
             </a:pPr>
             <a:r>
-              <a:rPr lang="en-IN" sz="900" dirty="0">
+              <a:rPr lang="en-IN" sz="890" dirty="0">
                 <a:solidFill>
                   <a:schemeClr val="tx1">
                     <a:lumMod val="75000"/>
@@ -7660,7 +7638,7 @@
               <a:t>Built a secure custodial </a:t>
             </a:r>
             <a:r>
-              <a:rPr lang="en-IN" sz="900" u="sng" dirty="0">
+              <a:rPr lang="en-IN" sz="890" u="sng" dirty="0">
                 <a:solidFill>
                   <a:schemeClr val="tx1">
                     <a:lumMod val="75000"/>
@@ -7671,15 +7649,15 @@
               <a:t>wallet architecture</a:t>
             </a:r>
             <a:r>
-              <a:rPr lang="en-IN" sz="900" dirty="0">
-                <a:solidFill>
-                  <a:schemeClr val="tx1">
-                    <a:lumMod val="75000"/>
-                    <a:lumOff val="25000"/>
-                  </a:schemeClr>
-                </a:solidFill>
-              </a:rPr>
-              <a:t> with HD key derivation from a master seed, per-user derivation paths, custom key rotation, and decoupled encrypted key storage with obfuscation | Rust.</a:t>
+              <a:rPr lang="en-IN" sz="890" dirty="0">
+                <a:solidFill>
+                  <a:schemeClr val="tx1">
+                    <a:lumMod val="75000"/>
+                    <a:lumOff val="25000"/>
+                  </a:schemeClr>
+                </a:solidFill>
+              </a:rPr>
+              <a:t> with HD key derivation from a master seed, per-user derivation paths, custom key rotation mechanism and decoupled encrypted key storage with obfuscation | Rust.</a:t>
             </a:r>
           </a:p>
           <a:p>
@@ -7691,7 +7669,7 @@
               <a:buChar char="•"/>
             </a:pPr>
             <a:r>
-              <a:rPr lang="en-IN" sz="900" dirty="0">
+              <a:rPr lang="en-IN" sz="890" dirty="0">
                 <a:solidFill>
                   <a:schemeClr val="tx1">
                     <a:lumMod val="75000"/>
@@ -7711,7 +7689,7 @@
               <a:buChar char="•"/>
             </a:pPr>
             <a:r>
-              <a:rPr lang="en-IN" sz="900" dirty="0">
+              <a:rPr lang="en-IN" sz="890" dirty="0">
                 <a:solidFill>
                   <a:schemeClr val="tx1">
                     <a:lumMod val="75000"/>
@@ -7722,7 +7700,7 @@
               <a:t>Built a scalable API-</a:t>
             </a:r>
             <a:r>
-              <a:rPr lang="en-IN" sz="900" dirty="0" err="1">
+              <a:rPr lang="en-IN" sz="890" dirty="0" err="1">
                 <a:solidFill>
                   <a:schemeClr val="tx1">
                     <a:lumMod val="75000"/>
@@ -7733,7 +7711,7 @@
               <a:t>aaS</a:t>
             </a:r>
             <a:r>
-              <a:rPr lang="en-IN" sz="900" dirty="0">
+              <a:rPr lang="en-IN" sz="890" dirty="0">
                 <a:solidFill>
                   <a:schemeClr val="tx1">
                     <a:lumMod val="75000"/>
@@ -7744,7 +7722,7 @@
               <a:t> for builders to access low-cost gasless payment infra, auth, wallet, ... Released </a:t>
             </a:r>
             <a:r>
-              <a:rPr lang="en-IN" sz="900" dirty="0">
+              <a:rPr lang="en-IN" sz="890" dirty="0">
                 <a:solidFill>
                   <a:schemeClr val="tx1">
                     <a:lumMod val="75000"/>
@@ -7756,7 +7734,7 @@
               <a:t>developer-kit</a:t>
             </a:r>
             <a:r>
-              <a:rPr lang="en-IN" sz="900" dirty="0">
+              <a:rPr lang="en-IN" sz="890" dirty="0">
                 <a:solidFill>
                   <a:schemeClr val="tx1">
                     <a:lumMod val="75000"/>
@@ -7776,7 +7754,7 @@
               <a:buChar char="•"/>
             </a:pPr>
             <a:r>
-              <a:rPr lang="en-IN" sz="900" dirty="0">
+              <a:rPr lang="en-IN" sz="890" dirty="0">
                 <a:solidFill>
                   <a:schemeClr val="tx1">
                     <a:lumMod val="75000"/>
@@ -7787,7 +7765,7 @@
               <a:t>Designed and developed a modern, high-performance </a:t>
             </a:r>
             <a:r>
-              <a:rPr lang="en-IN" sz="900" u="sng" dirty="0">
+              <a:rPr lang="en-IN" sz="890" u="sng" dirty="0">
                 <a:solidFill>
                   <a:schemeClr val="tx1">
                     <a:lumMod val="75000"/>
@@ -7798,7 +7776,7 @@
               <a:t>WASM web app</a:t>
             </a:r>
             <a:r>
-              <a:rPr lang="en-IN" sz="900" dirty="0">
+              <a:rPr lang="en-IN" sz="890" dirty="0">
                 <a:solidFill>
                   <a:schemeClr val="tx1">
                     <a:lumMod val="75000"/>
@@ -7809,7 +7787,7 @@
               <a:t> with a clean, responsive UI using Tailwind CSS &amp; </a:t>
             </a:r>
             <a:r>
-              <a:rPr lang="en-US" sz="900" dirty="0">
+              <a:rPr lang="en-US" sz="890" dirty="0">
                 <a:solidFill>
                   <a:schemeClr val="tx1">
                     <a:lumMod val="75000"/>
@@ -7820,7 +7798,7 @@
               <a:t>(</a:t>
             </a:r>
             <a:r>
-              <a:rPr lang="en-US" sz="900" dirty="0" err="1">
+              <a:rPr lang="en-US" sz="890" dirty="0" err="1">
                 <a:solidFill>
                   <a:schemeClr val="tx1">
                     <a:lumMod val="75000"/>
@@ -7831,7 +7809,7 @@
               <a:t>Dioxus</a:t>
             </a:r>
             <a:r>
-              <a:rPr lang="en-US" sz="900" dirty="0">
+              <a:rPr lang="en-US" sz="890" dirty="0">
                 <a:solidFill>
                   <a:schemeClr val="tx1">
                     <a:lumMod val="75000"/>
@@ -7851,7 +7829,7 @@
               <a:buChar char="•"/>
             </a:pPr>
             <a:r>
-              <a:rPr lang="en-IN" sz="900" dirty="0">
+              <a:rPr lang="en-IN" sz="890" dirty="0">
                 <a:solidFill>
                   <a:schemeClr val="tx1">
                     <a:lumMod val="75000"/>
@@ -7871,7 +7849,7 @@
               <a:buChar char="•"/>
             </a:pPr>
             <a:r>
-              <a:rPr lang="en-US" sz="900" dirty="0">
+              <a:rPr lang="en-US" sz="890" dirty="0">
                 <a:solidFill>
                   <a:schemeClr val="tx1">
                     <a:lumMod val="75000"/>
@@ -7882,7 +7860,7 @@
               <a:t>Developed &amp; deployed the </a:t>
             </a:r>
             <a:r>
-              <a:rPr lang="en-US" sz="900" u="sng" dirty="0">
+              <a:rPr lang="en-US" sz="890" u="sng" dirty="0">
                 <a:solidFill>
                   <a:schemeClr val="tx1">
                     <a:lumMod val="75000"/>
@@ -7893,7 +7871,7 @@
               <a:t>Backend with API, Proxy servers </a:t>
             </a:r>
             <a:r>
-              <a:rPr lang="en-US" sz="900" dirty="0">
+              <a:rPr lang="en-US" sz="890" dirty="0">
                 <a:solidFill>
                   <a:schemeClr val="tx1">
                     <a:lumMod val="75000"/>
@@ -7913,7 +7891,7 @@
               <a:buChar char="•"/>
             </a:pPr>
             <a:r>
-              <a:rPr lang="en-US" sz="900" dirty="0">
+              <a:rPr lang="en-US" sz="890" dirty="0">
                 <a:solidFill>
                   <a:schemeClr val="tx1">
                     <a:lumMod val="75000"/>
@@ -7924,7 +7902,7 @@
               <a:t>Built the interactive </a:t>
             </a:r>
             <a:r>
-              <a:rPr lang="en-US" sz="900" u="sng" dirty="0">
+              <a:rPr lang="en-US" sz="890" u="sng" dirty="0">
                 <a:solidFill>
                   <a:schemeClr val="tx1">
                     <a:lumMod val="75000"/>
@@ -7935,7 +7913,7 @@
               <a:t>Telegram Bot</a:t>
             </a:r>
             <a:r>
-              <a:rPr lang="en-US" sz="900" dirty="0">
+              <a:rPr lang="en-US" sz="890" dirty="0">
                 <a:solidFill>
                   <a:schemeClr val="tx1">
                     <a:lumMod val="75000"/>
@@ -7964,7 +7942,7 @@
         </p:nvCxnSpPr>
         <p:spPr>
           <a:xfrm>
-            <a:off x="11442" y="3596741"/>
+            <a:off x="11442" y="3575801"/>
             <a:ext cx="6884696" cy="0"/>
           </a:xfrm>
           <a:prstGeom prst="line">

</xml_diff>